<commit_message>
test: expand to 20 test cases, add risk assessment and feasibility proof
Eight test cases were too few for the midterm review. Add twelve (TC-09 to
TC-20) covering reschedule collisions, buffer, duration/week/per-booker
limits, repeated cancel, duplicate seat, mixed event types, high load and
independent slots. Official run on macOS: 13/20 detect a defect (12 race, 1
logic), 7 pass in both modes, sequential control passes 19/20.

Five new defects D7-D11, each reproduced with plain curl (repro-curl-2.sh).
Feasibility evidence: sequential control, N=2 sensitivity, fix experiments
(unique attendee index flips TC-16 from FAIL 10/10 to PASS 10/10), and an
exclusion constraint that restores I1/I3 but exposes HTTP 500.

Rebuild the report (61 pages), the 17-slide deck, the one-page slide and the
presentation guide; add docs/DANH_GIA_RUI_RO.md.

Co-Authored-By: Claude Sonnet 5.5 <noreply@anthropic.com>
</commit_message>
<xml_diff>
--- a/docs/SLIDE_1_TRANG_TRINH_BAY_LOP.pptx
+++ b/docs/SLIDE_1_TRANG_TRINH_BAY_LOP.pptx
@@ -502,7 +502,7 @@
           <a:p>
             <a:r>
               <a:rPr lang="en-US" dirty="0"/>
-              <a:t>Một slide tóm tắt nội dung nhóm đã hoàn thành đến thời điểm hiện tại, dùng để trình bày trước lớp. Nhóm đã dựng Cal.com, viết bộ test tự động gửi yêu cầu đồng thời và kiểm tra trực tiếp cơ sở dữ liệu, chạy 8 test case mỗi cái 10 vòng ở hai chế độ, tìm được 6 lỗi thật và tái hiện độc lập bằng curl, và chạy lại trên máy Windows cho cùng kết quả. Chi phí 0 đồng. Việc còn lại là test qua giao diện, đề xuất sửa và báo lỗi cho Cal.com.</a:t>
+              <a:t>Một slide tóm tắt nội dung nhóm đã hoàn thành đến thời điểm hiện tại, dùng để trình bày trước lớp. Nhóm đã dựng Cal.com, viết bộ test tự động gửi yêu cầu đồng thời và kiểm tra trực tiếp cơ sở dữ liệu, chạy 20 test case mỗi cái 10 vòng ở hai chế độ, tìm được 11 lỗi thật và tái hiện độc lập bằng curl, và 8 test case đầu chạy lại trên máy Windows cho cùng kết quả. Chi phí 0 đồng. Việc còn lại là test qua giao diện, đề xuất sửa và báo lỗi cho Cal.com.</a:t>
             </a:r>
             <a:endParaRPr lang="en-US" dirty="0"/>
           </a:p>
@@ -947,7 +947,7 @@
                 <a:ea typeface="Calibri" pitchFamily="34" charset="-122"/>
                 <a:cs typeface="Calibri" pitchFamily="34" charset="-120"/>
               </a:rPr>
-              <a:t>Kiểm thử race condition cho Cal.com: 6 lỗi thật, tái hiện trên 2 máy</a:t>
+              <a:t>Kiểm thử race condition cho Cal.com: 11 lỗi thật qua 20 test case</a:t>
             </a:r>
             <a:endParaRPr lang="en-US" sz="3000" dirty="0"/>
           </a:p>
@@ -1098,7 +1098,7 @@
                 <a:ea typeface="Calibri" pitchFamily="34" charset="-122"/>
                 <a:cs typeface="Calibri" pitchFamily="34" charset="-120"/>
               </a:rPr>
-              <a:t>8 test case × 10 vòng, có nhóm đối chứng tuần tự</a:t>
+              <a:t>20 test case × 10 vòng, có nhóm đối chứng tuần tự</a:t>
             </a:r>
             <a:endParaRPr lang="en-US" sz="1500" dirty="0"/>
           </a:p>
@@ -1119,7 +1119,7 @@
                 <a:ea typeface="Calibri" pitchFamily="34" charset="-122"/>
                 <a:cs typeface="Calibri" pitchFamily="34" charset="-120"/>
               </a:rPr>
-              <a:t>6 lỗi (5 race, 1 logic), tái hiện độc lập bằng curl</a:t>
+              <a:t>11 lỗi (10 race, 1 logic), tái hiện độc lập bằng curl</a:t>
             </a:r>
             <a:endParaRPr lang="en-US" sz="1500" dirty="0"/>
           </a:p>
@@ -1140,7 +1140,7 @@
                 <a:ea typeface="Calibri" pitchFamily="34" charset="-122"/>
                 <a:cs typeface="Calibri" pitchFamily="34" charset="-120"/>
               </a:rPr>
-              <a:t>Chạy lại trên máy Windows: khớp 8/8</a:t>
+              <a:t>Đánh giá rủi ro; 8 test case đầu khớp 8/8 trên Windows</a:t>
             </a:r>
             <a:endParaRPr lang="en-US" sz="1500" dirty="0"/>
           </a:p>
@@ -1532,7 +1532,7 @@
                           <a:ea typeface="Calibri" pitchFamily="34" charset="-122"/>
                           <a:cs typeface="Calibri" pitchFamily="34" charset="-120"/>
                         </a:rPr>
-                        <a:t>TC-01, TC-04</a:t>
+                        <a:t>7 TC (01, 04, 09, 10, 18, 19, 20)</a:t>
                       </a:r>
                       <a:endParaRPr lang="en-US" sz="1300" dirty="0">
                         <a:latin typeface="Calibri" charset="0"/>
@@ -1806,7 +1806,7 @@
                           <a:ea typeface="Calibri" pitchFamily="34" charset="-122"/>
                           <a:cs typeface="Calibri" pitchFamily="34" charset="-120"/>
                         </a:rPr>
-                        <a:t>TC-02, 03, 05, 07, 08</a:t>
+                        <a:t>12 TC (02, 03, 05, 07, 08, 11–17)</a:t>
                       </a:r>
                       <a:endParaRPr lang="en-US" sz="1300" dirty="0">
                         <a:latin typeface="Calibri" charset="0"/>
@@ -2373,7 +2373,7 @@
                 <a:ea typeface="Calibri" pitchFamily="34" charset="-122"/>
                 <a:cs typeface="Calibri" pitchFamily="34" charset="-120"/>
               </a:rPr>
-              <a:t>Mã HTTP đều 200 nhưng CSDL sai; chỉ cần 2 yêu cầu đồng thời là đủ gây lỗi.</a:t>
+              <a:t>Mã HTTP đều 200 nhưng CSDL sai; chỉ cần 2 yêu cầu đồng thời. Nặng nhất: D1 chồng giờ, D6 vượt giới hạn.</a:t>
             </a:r>
             <a:endParaRPr lang="en-US" sz="1400" dirty="0"/>
           </a:p>
@@ -2478,7 +2478,7 @@
                 <a:ea typeface="Calibri" pitchFamily="34" charset="-122"/>
                 <a:cs typeface="Calibri" pitchFamily="34" charset="-120"/>
               </a:rPr>
-              <a:t>0 đồng · lượt chạy chính thức dưới 3 phút máy · bộ test khoảng 970 dòng mã</a:t>
+              <a:t>0 đồng · 20 test case chạy lại khoảng 8 phút máy · bộ test khoảng 1 600 dòng mã</a:t>
             </a:r>
             <a:endParaRPr lang="en-US" sz="1400" dirty="0"/>
           </a:p>

</xml_diff>